<commit_message>
feat: added slide deck
</commit_message>
<xml_diff>
--- a/Analysis & Recommendations.pptx
+++ b/Analysis & Recommendations.pptx
@@ -107,6 +107,11 @@
       </a:defRPr>
     </a:lvl9pPr>
   </p:defaultTextStyle>
+  <p:extLst>
+    <p:ext uri="{EFAFB233-063F-42B5-8137-9DF3F51BA10A}">
+      <p15:sldGuideLst xmlns:p15="http://schemas.microsoft.com/office/powerpoint/2012/main"/>
+    </p:ext>
+  </p:extLst>
 </p:presentation>
 </file>
 
@@ -3820,13 +3825,13 @@
         </p:nvSpPr>
         <p:spPr>
           <a:xfrm>
-            <a:off x="838200" y="1588558"/>
-            <a:ext cx="10515600" cy="4351338"/>
+            <a:off x="481149" y="1562432"/>
+            <a:ext cx="6189616" cy="4351338"/>
           </a:xfrm>
         </p:spPr>
         <p:txBody>
           <a:bodyPr anchor="ctr" anchorCtr="0">
-            <a:normAutofit/>
+            <a:normAutofit fontScale="92500" lnSpcReduction="20000"/>
           </a:bodyPr>
           <a:lstStyle/>
           <a:p>
@@ -4101,6 +4106,67 @@
           </a:p>
         </p:txBody>
       </p:sp>
+      <p:pic>
+        <p:nvPicPr>
+          <p:cNvPr id="7" name="Image 6">
+            <a:extLst>
+              <a:ext uri="{FF2B5EF4-FFF2-40B4-BE49-F238E27FC236}">
+                <a16:creationId xmlns:a16="http://schemas.microsoft.com/office/drawing/2014/main" id="{8244DAA2-CEDA-B57F-4E3C-72C5EC2AF521}"/>
+              </a:ext>
+            </a:extLst>
+          </p:cNvPr>
+          <p:cNvPicPr>
+            <a:picLocks noChangeAspect="1"/>
+          </p:cNvPicPr>
+          <p:nvPr/>
+        </p:nvPicPr>
+        <p:blipFill>
+          <a:blip r:embed="rId2"/>
+          <a:stretch>
+            <a:fillRect/>
+          </a:stretch>
+        </p:blipFill>
+        <p:spPr>
+          <a:xfrm>
+            <a:off x="6670765" y="473883"/>
+            <a:ext cx="5258753" cy="2626718"/>
+          </a:xfrm>
+          <a:prstGeom prst="rect">
+            <a:avLst/>
+          </a:prstGeom>
+        </p:spPr>
+      </p:pic>
+      <p:pic>
+        <p:nvPicPr>
+          <p:cNvPr id="9" name="Image 8">
+            <a:extLst>
+              <a:ext uri="{FF2B5EF4-FFF2-40B4-BE49-F238E27FC236}">
+                <a16:creationId xmlns:a16="http://schemas.microsoft.com/office/drawing/2014/main" id="{B79308EC-A534-E4E1-71F2-7E339274B9D1}"/>
+              </a:ext>
+            </a:extLst>
+          </p:cNvPr>
+          <p:cNvPicPr>
+            <a:picLocks noChangeAspect="1"/>
+          </p:cNvPicPr>
+          <p:nvPr/>
+        </p:nvPicPr>
+        <p:blipFill>
+          <a:blip r:embed="rId3"/>
+          <a:srcRect l="51786"/>
+          <a:stretch>
+            <a:fillRect/>
+          </a:stretch>
+        </p:blipFill>
+        <p:spPr>
+          <a:xfrm>
+            <a:off x="7774575" y="3194243"/>
+            <a:ext cx="3579225" cy="3151015"/>
+          </a:xfrm>
+          <a:prstGeom prst="rect">
+            <a:avLst/>
+          </a:prstGeom>
+        </p:spPr>
+      </p:pic>
     </p:spTree>
     <p:extLst>
       <p:ext uri="{BB962C8B-B14F-4D97-AF65-F5344CB8AC3E}">

</xml_diff>